<commit_message>
Add architecture diagrams to project presentation
Agent-Logs-Url: https://github.com/the3miaphysite3engineer3/Virtual-Hospital/sessions/f84d9f69-0791-472b-9dc6-10499fcd67d4

Co-authored-by: the3miaphysite3engineer3 <71743801+the3miaphysite3engineer3@users.noreply.github.com>
</commit_message>
<xml_diff>
--- a/docs/Virtual-Hospital-Project-Presentation.pptx
+++ b/docs/Virtual-Hospital-Project-Presentation.pptx
@@ -18,6 +18,7 @@
     <p:sldId id="266" r:id="rId17"/>
     <p:sldId id="267" r:id="rId18"/>
     <p:sldId id="268" r:id="rId19"/>
+    <p:sldId id="269" r:id="rId20"/>
   </p:sldIdLst>
   <p:sldSz cx="9144000" cy="6858000" type="screen4x3"/>
   <p:notesSz cx="6858000" cy="9144000"/>
@@ -3529,6 +3530,479 @@
 </p:sld>
 </file>
 
+<file path=ppt/slides/slide14.xml><?xml version="1.0" encoding="utf-8"?>
+<p:sld xmlns:a="http://schemas.openxmlformats.org/drawingml/2006/main" xmlns:p="http://schemas.openxmlformats.org/presentationml/2006/main" xmlns:r="http://schemas.openxmlformats.org/officeDocument/2006/relationships">
+  <p:cSld>
+    <p:spTree>
+      <p:nvGrpSpPr>
+        <p:cNvPr id="1" name=""/>
+        <p:cNvGrpSpPr/>
+        <p:nvPr/>
+      </p:nvGrpSpPr>
+      <p:grpSpPr/>
+      <p:sp>
+        <p:nvSpPr>
+          <p:cNvPr id="2" name="Title 1"/>
+          <p:cNvSpPr>
+            <a:spLocks noGrp="1"/>
+          </p:cNvSpPr>
+          <p:nvPr>
+            <p:ph type="title"/>
+          </p:nvPr>
+        </p:nvSpPr>
+        <p:spPr/>
+        <p:txBody>
+          <a:bodyPr/>
+          <a:lstStyle/>
+          <a:p>
+            <a:r>
+              <a:t>Hybrid Cloud Backup Architecture</a:t>
+            </a:r>
+          </a:p>
+        </p:txBody>
+      </p:sp>
+      <p:sp>
+        <p:nvSpPr>
+          <p:cNvPr id="3" name="Rounded Rectangle 2"/>
+          <p:cNvSpPr/>
+          <p:nvPr/>
+        </p:nvSpPr>
+        <p:spPr>
+          <a:xfrm>
+            <a:off x="548640" y="1554480"/>
+            <a:ext cx="3931920" cy="4023360"/>
+          </a:xfrm>
+          <a:prstGeom prst="roundRect">
+            <a:avLst/>
+          </a:prstGeom>
+          <a:solidFill>
+            <a:srgbClr val="F2F2F2"/>
+          </a:solidFill>
+          <a:ln>
+            <a:solidFill>
+              <a:srgbClr val="7F7F7F"/>
+            </a:solidFill>
+          </a:ln>
+        </p:spPr>
+        <p:style>
+          <a:lnRef idx="1">
+            <a:schemeClr val="accent1"/>
+          </a:lnRef>
+          <a:fillRef idx="3">
+            <a:schemeClr val="accent1"/>
+          </a:fillRef>
+          <a:effectRef idx="2">
+            <a:schemeClr val="accent1"/>
+          </a:effectRef>
+          <a:fontRef idx="minor">
+            <a:schemeClr val="lt1"/>
+          </a:fontRef>
+        </p:style>
+        <p:txBody>
+          <a:bodyPr rtlCol="0" anchor="ctr"/>
+          <a:lstStyle/>
+          <a:p>
+            <a:pPr>
+              <a:defRPr sz="1600"/>
+            </a:pPr>
+            <a:r>
+              <a:t>On-Prem VM</a:t>
+            </a:r>
+          </a:p>
+        </p:txBody>
+      </p:sp>
+      <p:sp>
+        <p:nvSpPr>
+          <p:cNvPr id="4" name="Rounded Rectangle 3"/>
+          <p:cNvSpPr/>
+          <p:nvPr/>
+        </p:nvSpPr>
+        <p:spPr>
+          <a:xfrm>
+            <a:off x="1005840" y="2468880"/>
+            <a:ext cx="3017520" cy="1097280"/>
+          </a:xfrm>
+          <a:prstGeom prst="roundRect">
+            <a:avLst/>
+          </a:prstGeom>
+          <a:solidFill>
+            <a:srgbClr val="E9F5E9"/>
+          </a:solidFill>
+          <a:ln>
+            <a:solidFill>
+              <a:srgbClr val="386092"/>
+            </a:solidFill>
+          </a:ln>
+        </p:spPr>
+        <p:style>
+          <a:lnRef idx="1">
+            <a:schemeClr val="accent1"/>
+          </a:lnRef>
+          <a:fillRef idx="3">
+            <a:schemeClr val="accent1"/>
+          </a:fillRef>
+          <a:effectRef idx="2">
+            <a:schemeClr val="accent1"/>
+          </a:effectRef>
+          <a:fontRef idx="minor">
+            <a:schemeClr val="lt1"/>
+          </a:fontRef>
+        </p:style>
+        <p:txBody>
+          <a:bodyPr rtlCol="0" anchor="ctr"/>
+          <a:lstStyle/>
+          <a:p>
+            <a:r>
+              <a:t>MySQL container</a:t>
+            </a:r>
+          </a:p>
+          <a:p>
+            <a:r>
+              <a:t>Nightly mysqldump</a:t>
+            </a:r>
+          </a:p>
+        </p:txBody>
+      </p:sp>
+      <p:sp>
+        <p:nvSpPr>
+          <p:cNvPr id="5" name="Rounded Rectangle 4"/>
+          <p:cNvSpPr/>
+          <p:nvPr/>
+        </p:nvSpPr>
+        <p:spPr>
+          <a:xfrm>
+            <a:off x="5120640" y="1554480"/>
+            <a:ext cx="3657600" cy="4023360"/>
+          </a:xfrm>
+          <a:prstGeom prst="roundRect">
+            <a:avLst/>
+          </a:prstGeom>
+          <a:solidFill>
+            <a:srgbClr val="E2EFDA"/>
+          </a:solidFill>
+          <a:ln>
+            <a:solidFill>
+              <a:srgbClr val="548235"/>
+            </a:solidFill>
+          </a:ln>
+        </p:spPr>
+        <p:style>
+          <a:lnRef idx="1">
+            <a:schemeClr val="accent1"/>
+          </a:lnRef>
+          <a:fillRef idx="3">
+            <a:schemeClr val="accent1"/>
+          </a:fillRef>
+          <a:effectRef idx="2">
+            <a:schemeClr val="accent1"/>
+          </a:effectRef>
+          <a:fontRef idx="minor">
+            <a:schemeClr val="lt1"/>
+          </a:fontRef>
+        </p:style>
+        <p:txBody>
+          <a:bodyPr rtlCol="0" anchor="ctr"/>
+          <a:lstStyle/>
+          <a:p>
+            <a:pPr>
+              <a:defRPr sz="1600"/>
+            </a:pPr>
+            <a:r>
+              <a:t>AWS Cloud</a:t>
+            </a:r>
+          </a:p>
+        </p:txBody>
+      </p:sp>
+      <p:sp>
+        <p:nvSpPr>
+          <p:cNvPr id="6" name="Rounded Rectangle 5"/>
+          <p:cNvSpPr/>
+          <p:nvPr/>
+        </p:nvSpPr>
+        <p:spPr>
+          <a:xfrm>
+            <a:off x="5577840" y="2286000"/>
+            <a:ext cx="2743200" cy="914400"/>
+          </a:xfrm>
+          <a:prstGeom prst="roundRect">
+            <a:avLst/>
+          </a:prstGeom>
+          <a:solidFill>
+            <a:srgbClr val="FFFFFF"/>
+          </a:solidFill>
+          <a:ln>
+            <a:solidFill>
+              <a:srgbClr val="548235"/>
+            </a:solidFill>
+          </a:ln>
+        </p:spPr>
+        <p:style>
+          <a:lnRef idx="1">
+            <a:schemeClr val="accent1"/>
+          </a:lnRef>
+          <a:fillRef idx="3">
+            <a:schemeClr val="accent1"/>
+          </a:fillRef>
+          <a:effectRef idx="2">
+            <a:schemeClr val="accent1"/>
+          </a:effectRef>
+          <a:fontRef idx="minor">
+            <a:schemeClr val="lt1"/>
+          </a:fontRef>
+        </p:style>
+        <p:txBody>
+          <a:bodyPr rtlCol="0" anchor="ctr"/>
+          <a:lstStyle/>
+          <a:p>
+            <a:r>
+              <a:t>S3 Bucket</a:t>
+            </a:r>
+          </a:p>
+          <a:p>
+            <a:r>
+              <a:t>Encrypted backups</a:t>
+            </a:r>
+          </a:p>
+        </p:txBody>
+      </p:sp>
+      <p:sp>
+        <p:nvSpPr>
+          <p:cNvPr id="7" name="Rounded Rectangle 6"/>
+          <p:cNvSpPr/>
+          <p:nvPr/>
+        </p:nvSpPr>
+        <p:spPr>
+          <a:xfrm>
+            <a:off x="5577840" y="3657600"/>
+            <a:ext cx="2743200" cy="914400"/>
+          </a:xfrm>
+          <a:prstGeom prst="roundRect">
+            <a:avLst/>
+          </a:prstGeom>
+          <a:solidFill>
+            <a:srgbClr val="FFFFFF"/>
+          </a:solidFill>
+          <a:ln>
+            <a:solidFill>
+              <a:srgbClr val="548235"/>
+            </a:solidFill>
+          </a:ln>
+        </p:spPr>
+        <p:style>
+          <a:lnRef idx="1">
+            <a:schemeClr val="accent1"/>
+          </a:lnRef>
+          <a:fillRef idx="3">
+            <a:schemeClr val="accent1"/>
+          </a:fillRef>
+          <a:effectRef idx="2">
+            <a:schemeClr val="accent1"/>
+          </a:effectRef>
+          <a:fontRef idx="minor">
+            <a:schemeClr val="lt1"/>
+          </a:fontRef>
+        </p:style>
+        <p:txBody>
+          <a:bodyPr rtlCol="0" anchor="ctr"/>
+          <a:lstStyle/>
+          <a:p>
+            <a:r>
+              <a:t>RDS (optional DR)</a:t>
+            </a:r>
+          </a:p>
+        </p:txBody>
+      </p:sp>
+      <p:sp>
+        <p:nvSpPr>
+          <p:cNvPr id="8" name="Cloud 7"/>
+          <p:cNvSpPr/>
+          <p:nvPr/>
+        </p:nvSpPr>
+        <p:spPr>
+          <a:xfrm>
+            <a:off x="4023360" y="2743200"/>
+            <a:ext cx="1097280" cy="822960"/>
+          </a:xfrm>
+          <a:prstGeom prst="cloud">
+            <a:avLst/>
+          </a:prstGeom>
+          <a:solidFill>
+            <a:srgbClr val="DDEBF7"/>
+          </a:solidFill>
+          <a:ln>
+            <a:solidFill>
+              <a:srgbClr val="386092"/>
+            </a:solidFill>
+          </a:ln>
+        </p:spPr>
+        <p:style>
+          <a:lnRef idx="1">
+            <a:schemeClr val="accent1"/>
+          </a:lnRef>
+          <a:fillRef idx="3">
+            <a:schemeClr val="accent1"/>
+          </a:fillRef>
+          <a:effectRef idx="2">
+            <a:schemeClr val="accent1"/>
+          </a:effectRef>
+          <a:fontRef idx="minor">
+            <a:schemeClr val="lt1"/>
+          </a:fontRef>
+        </p:style>
+        <p:txBody>
+          <a:bodyPr rtlCol="0" anchor="ctr"/>
+          <a:lstStyle/>
+          <a:p>
+            <a:r>
+              <a:t>Internet</a:t>
+            </a:r>
+          </a:p>
+        </p:txBody>
+      </p:sp>
+      <p:cxnSp>
+        <p:nvCxnSpPr>
+          <p:cNvPr id="9" name="Connector 8"/>
+          <p:cNvCxnSpPr/>
+          <p:nvPr/>
+        </p:nvCxnSpPr>
+        <p:spPr>
+          <a:xfrm>
+            <a:off x="4023360" y="3017520"/>
+            <a:ext cx="0" cy="0"/>
+          </a:xfrm>
+          <a:prstGeom prst="line">
+            <a:avLst/>
+          </a:prstGeom>
+          <a:ln w="25400">
+            <a:solidFill>
+              <a:srgbClr val="386092"/>
+            </a:solidFill>
+          </a:ln>
+        </p:spPr>
+        <p:style>
+          <a:lnRef idx="2">
+            <a:schemeClr val="accent1"/>
+          </a:lnRef>
+          <a:fillRef idx="0">
+            <a:schemeClr val="accent1"/>
+          </a:fillRef>
+          <a:effectRef idx="1">
+            <a:schemeClr val="accent1"/>
+          </a:effectRef>
+          <a:fontRef idx="minor">
+            <a:schemeClr val="tx1"/>
+          </a:fontRef>
+        </p:style>
+      </p:cxnSp>
+      <p:cxnSp>
+        <p:nvCxnSpPr>
+          <p:cNvPr id="10" name="Connector 9"/>
+          <p:cNvCxnSpPr/>
+          <p:nvPr/>
+        </p:nvCxnSpPr>
+        <p:spPr>
+          <a:xfrm>
+            <a:off x="4023360" y="2971800"/>
+            <a:ext cx="1097280" cy="0"/>
+          </a:xfrm>
+          <a:prstGeom prst="line">
+            <a:avLst/>
+          </a:prstGeom>
+          <a:ln w="25400">
+            <a:solidFill>
+              <a:srgbClr val="386092"/>
+            </a:solidFill>
+          </a:ln>
+        </p:spPr>
+        <p:style>
+          <a:lnRef idx="2">
+            <a:schemeClr val="accent1"/>
+          </a:lnRef>
+          <a:fillRef idx="0">
+            <a:schemeClr val="accent1"/>
+          </a:fillRef>
+          <a:effectRef idx="1">
+            <a:schemeClr val="accent1"/>
+          </a:effectRef>
+          <a:fontRef idx="minor">
+            <a:schemeClr val="tx1"/>
+          </a:fontRef>
+        </p:style>
+      </p:cxnSp>
+      <p:cxnSp>
+        <p:nvCxnSpPr>
+          <p:cNvPr id="11" name="Connector 10"/>
+          <p:cNvCxnSpPr/>
+          <p:nvPr/>
+        </p:nvCxnSpPr>
+        <p:spPr>
+          <a:xfrm>
+            <a:off x="6949440" y="3200400"/>
+            <a:ext cx="0" cy="457200"/>
+          </a:xfrm>
+          <a:prstGeom prst="line">
+            <a:avLst/>
+          </a:prstGeom>
+          <a:ln w="25400">
+            <a:solidFill>
+              <a:srgbClr val="548235"/>
+            </a:solidFill>
+          </a:ln>
+        </p:spPr>
+        <p:style>
+          <a:lnRef idx="2">
+            <a:schemeClr val="accent1"/>
+          </a:lnRef>
+          <a:fillRef idx="0">
+            <a:schemeClr val="accent1"/>
+          </a:fillRef>
+          <a:effectRef idx="1">
+            <a:schemeClr val="accent1"/>
+          </a:effectRef>
+          <a:fontRef idx="minor">
+            <a:schemeClr val="tx1"/>
+          </a:fontRef>
+        </p:style>
+      </p:cxnSp>
+      <p:sp>
+        <p:nvSpPr>
+          <p:cNvPr id="12" name="TextBox 11"/>
+          <p:cNvSpPr txBox="1"/>
+          <p:nvPr/>
+        </p:nvSpPr>
+        <p:spPr>
+          <a:xfrm>
+            <a:off x="731520" y="5760720"/>
+            <a:ext cx="8046720" cy="411480"/>
+          </a:xfrm>
+          <a:prstGeom prst="rect">
+            <a:avLst/>
+          </a:prstGeom>
+          <a:noFill/>
+        </p:spPr>
+        <p:txBody>
+          <a:bodyPr wrap="none">
+            <a:spAutoFit/>
+          </a:bodyPr>
+          <a:lstStyle/>
+          <a:p>
+            <a:pPr>
+              <a:defRPr sz="1300" b="1"/>
+            </a:pPr>
+            <a:r>
+              <a:t>Data sovereignty on-prem + offsite resilience via S3 backups and optional RDS disaster recovery</a:t>
+            </a:r>
+          </a:p>
+        </p:txBody>
+      </p:sp>
+    </p:spTree>
+  </p:cSld>
+  <p:clrMapOvr>
+    <a:masterClrMapping/>
+  </p:clrMapOvr>
+</p:sld>
+</file>
+
 <file path=ppt/slides/slide2.xml><?xml version="1.0" encoding="utf-8"?>
 <p:sld xmlns:a="http://schemas.openxmlformats.org/drawingml/2006/main" xmlns:p="http://schemas.openxmlformats.org/presentationml/2006/main" xmlns:r="http://schemas.openxmlformats.org/officeDocument/2006/relationships">
   <p:cSld>
@@ -3855,68 +4329,494 @@
       </p:sp>
       <p:sp>
         <p:nvSpPr>
-          <p:cNvPr id="3" name="Content Placeholder 2"/>
-          <p:cNvSpPr>
-            <a:spLocks noGrp="1"/>
-          </p:cNvSpPr>
-          <p:nvPr>
-            <p:ph idx="1"/>
-          </p:nvPr>
-        </p:nvSpPr>
-        <p:spPr/>
-        <p:txBody>
-          <a:bodyPr/>
-          <a:lstStyle/>
-          <a:p>
-            <a:pPr>
-              <a:defRPr sz="2000"/>
-            </a:pPr>
-            <a:r>
-              <a:t>Laptop → VM (Ubuntu Server) → Docker Engine</a:t>
-            </a:r>
-          </a:p>
-          <a:p>
-            <a:pPr>
-              <a:defRPr sz="2000"/>
-            </a:pPr>
-            <a:r>
-              <a:t>MySQL container exposed on port 3306</a:t>
-            </a:r>
-          </a:p>
-          <a:p>
-            <a:pPr>
-              <a:defRPr sz="2000"/>
-            </a:pPr>
-            <a:r>
-              <a:t>Grafana container exposed on port 3000</a:t>
-            </a:r>
-          </a:p>
-          <a:p>
-            <a:pPr>
-              <a:defRPr sz="2000"/>
-            </a:pPr>
-            <a:r>
-              <a:t>Grafana connects to MySQL via provisioned datasource</a:t>
-            </a:r>
-          </a:p>
-          <a:p>
-            <a:pPr>
-              <a:defRPr sz="2000"/>
-            </a:pPr>
-            <a:r>
-              <a:t>Persistent named volumes: mysql_data, grafana_data</a:t>
-            </a:r>
-          </a:p>
-          <a:p>
-            <a:pPr>
-              <a:defRPr sz="2000"/>
-            </a:pPr>
-            <a:r>
-              <a:t>Optional hybrid cloud extension for AWS S3 backup / DR</a:t>
-            </a:r>
-          </a:p>
-        </p:txBody>
-      </p:sp>
+          <p:cNvPr id="3" name="Rounded Rectangle 2"/>
+          <p:cNvSpPr/>
+          <p:nvPr/>
+        </p:nvSpPr>
+        <p:spPr>
+          <a:xfrm>
+            <a:off x="2103120" y="1371600"/>
+            <a:ext cx="6400800" cy="4206240"/>
+          </a:xfrm>
+          <a:prstGeom prst="roundRect">
+            <a:avLst/>
+          </a:prstGeom>
+          <a:solidFill>
+            <a:srgbClr val="F2F2F2"/>
+          </a:solidFill>
+          <a:ln>
+            <a:solidFill>
+              <a:srgbClr val="7F7F7F"/>
+            </a:solidFill>
+          </a:ln>
+        </p:spPr>
+        <p:style>
+          <a:lnRef idx="1">
+            <a:schemeClr val="accent1"/>
+          </a:lnRef>
+          <a:fillRef idx="3">
+            <a:schemeClr val="accent1"/>
+          </a:fillRef>
+          <a:effectRef idx="2">
+            <a:schemeClr val="accent1"/>
+          </a:effectRef>
+          <a:fontRef idx="minor">
+            <a:schemeClr val="lt1"/>
+          </a:fontRef>
+        </p:style>
+        <p:txBody>
+          <a:bodyPr rtlCol="0" anchor="ctr"/>
+          <a:lstStyle/>
+          <a:p>
+            <a:pPr>
+              <a:defRPr sz="1600"/>
+            </a:pPr>
+            <a:r>
+              <a:t>Ubuntu VM (8 GB RAM, 4 CPU)</a:t>
+            </a:r>
+          </a:p>
+        </p:txBody>
+      </p:sp>
+      <p:sp>
+        <p:nvSpPr>
+          <p:cNvPr id="4" name="Rounded Rectangle 3"/>
+          <p:cNvSpPr/>
+          <p:nvPr/>
+        </p:nvSpPr>
+        <p:spPr>
+          <a:xfrm>
+            <a:off x="365760" y="2743200"/>
+            <a:ext cx="1463040" cy="1005840"/>
+          </a:xfrm>
+          <a:prstGeom prst="roundRect">
+            <a:avLst/>
+          </a:prstGeom>
+          <a:solidFill>
+            <a:srgbClr val="E7F1FF"/>
+          </a:solidFill>
+          <a:ln>
+            <a:solidFill>
+              <a:srgbClr val="386092"/>
+            </a:solidFill>
+          </a:ln>
+        </p:spPr>
+        <p:style>
+          <a:lnRef idx="1">
+            <a:schemeClr val="accent1"/>
+          </a:lnRef>
+          <a:fillRef idx="3">
+            <a:schemeClr val="accent1"/>
+          </a:fillRef>
+          <a:effectRef idx="2">
+            <a:schemeClr val="accent1"/>
+          </a:effectRef>
+          <a:fontRef idx="minor">
+            <a:schemeClr val="lt1"/>
+          </a:fontRef>
+        </p:style>
+        <p:txBody>
+          <a:bodyPr rtlCol="0" anchor="ctr"/>
+          <a:lstStyle/>
+          <a:p>
+            <a:r>
+              <a:t>Laptop</a:t>
+            </a:r>
+          </a:p>
+          <a:p>
+            <a:r>
+              <a:t>Browser</a:t>
+            </a:r>
+          </a:p>
+        </p:txBody>
+      </p:sp>
+      <p:sp>
+        <p:nvSpPr>
+          <p:cNvPr id="5" name="Rounded Rectangle 4"/>
+          <p:cNvSpPr/>
+          <p:nvPr/>
+        </p:nvSpPr>
+        <p:spPr>
+          <a:xfrm>
+            <a:off x="2560320" y="2011680"/>
+            <a:ext cx="5486400" cy="3108960"/>
+          </a:xfrm>
+          <a:prstGeom prst="roundRect">
+            <a:avLst/>
+          </a:prstGeom>
+          <a:solidFill>
+            <a:srgbClr val="FAFAFA"/>
+          </a:solidFill>
+          <a:ln>
+            <a:solidFill>
+              <a:srgbClr val="A6A6A6"/>
+            </a:solidFill>
+          </a:ln>
+        </p:spPr>
+        <p:style>
+          <a:lnRef idx="1">
+            <a:schemeClr val="accent1"/>
+          </a:lnRef>
+          <a:fillRef idx="3">
+            <a:schemeClr val="accent1"/>
+          </a:fillRef>
+          <a:effectRef idx="2">
+            <a:schemeClr val="accent1"/>
+          </a:effectRef>
+          <a:fontRef idx="minor">
+            <a:schemeClr val="lt1"/>
+          </a:fontRef>
+        </p:style>
+        <p:txBody>
+          <a:bodyPr rtlCol="0" anchor="ctr"/>
+          <a:lstStyle/>
+          <a:p>
+            <a:pPr>
+              <a:defRPr sz="1400"/>
+            </a:pPr>
+            <a:r>
+              <a:t>Docker Engine</a:t>
+            </a:r>
+          </a:p>
+        </p:txBody>
+      </p:sp>
+      <p:sp>
+        <p:nvSpPr>
+          <p:cNvPr id="6" name="Rounded Rectangle 5"/>
+          <p:cNvSpPr/>
+          <p:nvPr/>
+        </p:nvSpPr>
+        <p:spPr>
+          <a:xfrm>
+            <a:off x="2926080" y="2743200"/>
+            <a:ext cx="2103120" cy="1005840"/>
+          </a:xfrm>
+          <a:prstGeom prst="roundRect">
+            <a:avLst/>
+          </a:prstGeom>
+          <a:solidFill>
+            <a:srgbClr val="E9F5E9"/>
+          </a:solidFill>
+          <a:ln>
+            <a:solidFill>
+              <a:srgbClr val="386092"/>
+            </a:solidFill>
+          </a:ln>
+        </p:spPr>
+        <p:style>
+          <a:lnRef idx="1">
+            <a:schemeClr val="accent1"/>
+          </a:lnRef>
+          <a:fillRef idx="3">
+            <a:schemeClr val="accent1"/>
+          </a:fillRef>
+          <a:effectRef idx="2">
+            <a:schemeClr val="accent1"/>
+          </a:effectRef>
+          <a:fontRef idx="minor">
+            <a:schemeClr val="lt1"/>
+          </a:fontRef>
+        </p:style>
+        <p:txBody>
+          <a:bodyPr rtlCol="0" anchor="ctr"/>
+          <a:lstStyle/>
+          <a:p>
+            <a:r>
+              <a:t>MySQL 8.0</a:t>
+            </a:r>
+          </a:p>
+          <a:p>
+            <a:r>
+              <a:t>Port 3306</a:t>
+            </a:r>
+          </a:p>
+        </p:txBody>
+      </p:sp>
+      <p:sp>
+        <p:nvSpPr>
+          <p:cNvPr id="7" name="Rounded Rectangle 6"/>
+          <p:cNvSpPr/>
+          <p:nvPr/>
+        </p:nvSpPr>
+        <p:spPr>
+          <a:xfrm>
+            <a:off x="5486400" y="2743200"/>
+            <a:ext cx="2103120" cy="1005840"/>
+          </a:xfrm>
+          <a:prstGeom prst="roundRect">
+            <a:avLst/>
+          </a:prstGeom>
+          <a:solidFill>
+            <a:srgbClr val="E9F5E9"/>
+          </a:solidFill>
+          <a:ln>
+            <a:solidFill>
+              <a:srgbClr val="386092"/>
+            </a:solidFill>
+          </a:ln>
+        </p:spPr>
+        <p:style>
+          <a:lnRef idx="1">
+            <a:schemeClr val="accent1"/>
+          </a:lnRef>
+          <a:fillRef idx="3">
+            <a:schemeClr val="accent1"/>
+          </a:fillRef>
+          <a:effectRef idx="2">
+            <a:schemeClr val="accent1"/>
+          </a:effectRef>
+          <a:fontRef idx="minor">
+            <a:schemeClr val="lt1"/>
+          </a:fontRef>
+        </p:style>
+        <p:txBody>
+          <a:bodyPr rtlCol="0" anchor="ctr"/>
+          <a:lstStyle/>
+          <a:p>
+            <a:r>
+              <a:t>Grafana 10</a:t>
+            </a:r>
+          </a:p>
+          <a:p>
+            <a:r>
+              <a:t>Port 3000</a:t>
+            </a:r>
+          </a:p>
+        </p:txBody>
+      </p:sp>
+      <p:sp>
+        <p:nvSpPr>
+          <p:cNvPr id="8" name="Rounded Rectangle 7"/>
+          <p:cNvSpPr/>
+          <p:nvPr/>
+        </p:nvSpPr>
+        <p:spPr>
+          <a:xfrm>
+            <a:off x="2926080" y="4206240"/>
+            <a:ext cx="2103120" cy="731520"/>
+          </a:xfrm>
+          <a:prstGeom prst="roundRect">
+            <a:avLst/>
+          </a:prstGeom>
+          <a:solidFill>
+            <a:srgbClr val="FFF2CC"/>
+          </a:solidFill>
+          <a:ln>
+            <a:solidFill>
+              <a:srgbClr val="BF9000"/>
+            </a:solidFill>
+          </a:ln>
+        </p:spPr>
+        <p:style>
+          <a:lnRef idx="1">
+            <a:schemeClr val="accent1"/>
+          </a:lnRef>
+          <a:fillRef idx="3">
+            <a:schemeClr val="accent1"/>
+          </a:fillRef>
+          <a:effectRef idx="2">
+            <a:schemeClr val="accent1"/>
+          </a:effectRef>
+          <a:fontRef idx="minor">
+            <a:schemeClr val="lt1"/>
+          </a:fontRef>
+        </p:style>
+        <p:txBody>
+          <a:bodyPr rtlCol="0" anchor="ctr"/>
+          <a:lstStyle/>
+          <a:p>
+            <a:r>
+              <a:t>mysql_data</a:t>
+            </a:r>
+          </a:p>
+        </p:txBody>
+      </p:sp>
+      <p:sp>
+        <p:nvSpPr>
+          <p:cNvPr id="9" name="Rounded Rectangle 8"/>
+          <p:cNvSpPr/>
+          <p:nvPr/>
+        </p:nvSpPr>
+        <p:spPr>
+          <a:xfrm>
+            <a:off x="5486400" y="4206240"/>
+            <a:ext cx="2103120" cy="731520"/>
+          </a:xfrm>
+          <a:prstGeom prst="roundRect">
+            <a:avLst/>
+          </a:prstGeom>
+          <a:solidFill>
+            <a:srgbClr val="FFF2CC"/>
+          </a:solidFill>
+          <a:ln>
+            <a:solidFill>
+              <a:srgbClr val="BF9000"/>
+            </a:solidFill>
+          </a:ln>
+        </p:spPr>
+        <p:style>
+          <a:lnRef idx="1">
+            <a:schemeClr val="accent1"/>
+          </a:lnRef>
+          <a:fillRef idx="3">
+            <a:schemeClr val="accent1"/>
+          </a:fillRef>
+          <a:effectRef idx="2">
+            <a:schemeClr val="accent1"/>
+          </a:effectRef>
+          <a:fontRef idx="minor">
+            <a:schemeClr val="lt1"/>
+          </a:fontRef>
+        </p:style>
+        <p:txBody>
+          <a:bodyPr rtlCol="0" anchor="ctr"/>
+          <a:lstStyle/>
+          <a:p>
+            <a:r>
+              <a:t>grafana_data</a:t>
+            </a:r>
+          </a:p>
+        </p:txBody>
+      </p:sp>
+      <p:cxnSp>
+        <p:nvCxnSpPr>
+          <p:cNvPr id="10" name="Connector 9"/>
+          <p:cNvCxnSpPr/>
+          <p:nvPr/>
+        </p:nvCxnSpPr>
+        <p:spPr>
+          <a:xfrm>
+            <a:off x="1828800" y="3246120"/>
+            <a:ext cx="731520" cy="0"/>
+          </a:xfrm>
+          <a:prstGeom prst="line">
+            <a:avLst/>
+          </a:prstGeom>
+          <a:ln w="25400">
+            <a:solidFill>
+              <a:srgbClr val="386092"/>
+            </a:solidFill>
+          </a:ln>
+        </p:spPr>
+        <p:style>
+          <a:lnRef idx="2">
+            <a:schemeClr val="accent1"/>
+          </a:lnRef>
+          <a:fillRef idx="0">
+            <a:schemeClr val="accent1"/>
+          </a:fillRef>
+          <a:effectRef idx="1">
+            <a:schemeClr val="accent1"/>
+          </a:effectRef>
+          <a:fontRef idx="minor">
+            <a:schemeClr val="tx1"/>
+          </a:fontRef>
+        </p:style>
+      </p:cxnSp>
+      <p:cxnSp>
+        <p:nvCxnSpPr>
+          <p:cNvPr id="11" name="Connector 10"/>
+          <p:cNvCxnSpPr/>
+          <p:nvPr/>
+        </p:nvCxnSpPr>
+        <p:spPr>
+          <a:xfrm flipH="1">
+            <a:off x="5029200" y="3246120"/>
+            <a:ext cx="457200" cy="0"/>
+          </a:xfrm>
+          <a:prstGeom prst="line">
+            <a:avLst/>
+          </a:prstGeom>
+          <a:ln w="25400">
+            <a:solidFill>
+              <a:srgbClr val="386092"/>
+            </a:solidFill>
+          </a:ln>
+        </p:spPr>
+        <p:style>
+          <a:lnRef idx="2">
+            <a:schemeClr val="accent1"/>
+          </a:lnRef>
+          <a:fillRef idx="0">
+            <a:schemeClr val="accent1"/>
+          </a:fillRef>
+          <a:effectRef idx="1">
+            <a:schemeClr val="accent1"/>
+          </a:effectRef>
+          <a:fontRef idx="minor">
+            <a:schemeClr val="tx1"/>
+          </a:fontRef>
+        </p:style>
+      </p:cxnSp>
+      <p:cxnSp>
+        <p:nvCxnSpPr>
+          <p:cNvPr id="12" name="Connector 11"/>
+          <p:cNvCxnSpPr/>
+          <p:nvPr/>
+        </p:nvCxnSpPr>
+        <p:spPr>
+          <a:xfrm>
+            <a:off x="3977639" y="3749039"/>
+            <a:ext cx="0" cy="457201"/>
+          </a:xfrm>
+          <a:prstGeom prst="line">
+            <a:avLst/>
+          </a:prstGeom>
+          <a:ln w="25400">
+            <a:solidFill>
+              <a:srgbClr val="386092"/>
+            </a:solidFill>
+          </a:ln>
+        </p:spPr>
+        <p:style>
+          <a:lnRef idx="2">
+            <a:schemeClr val="accent1"/>
+          </a:lnRef>
+          <a:fillRef idx="0">
+            <a:schemeClr val="accent1"/>
+          </a:fillRef>
+          <a:effectRef idx="1">
+            <a:schemeClr val="accent1"/>
+          </a:effectRef>
+          <a:fontRef idx="minor">
+            <a:schemeClr val="tx1"/>
+          </a:fontRef>
+        </p:style>
+      </p:cxnSp>
+      <p:cxnSp>
+        <p:nvCxnSpPr>
+          <p:cNvPr id="13" name="Connector 12"/>
+          <p:cNvCxnSpPr/>
+          <p:nvPr/>
+        </p:nvCxnSpPr>
+        <p:spPr>
+          <a:xfrm>
+            <a:off x="6537960" y="3749039"/>
+            <a:ext cx="0" cy="457201"/>
+          </a:xfrm>
+          <a:prstGeom prst="line">
+            <a:avLst/>
+          </a:prstGeom>
+          <a:ln w="25400">
+            <a:solidFill>
+              <a:srgbClr val="386092"/>
+            </a:solidFill>
+          </a:ln>
+        </p:spPr>
+        <p:style>
+          <a:lnRef idx="2">
+            <a:schemeClr val="accent1"/>
+          </a:lnRef>
+          <a:fillRef idx="0">
+            <a:schemeClr val="accent1"/>
+          </a:fillRef>
+          <a:effectRef idx="1">
+            <a:schemeClr val="accent1"/>
+          </a:effectRef>
+          <a:fontRef idx="minor">
+            <a:schemeClr val="tx1"/>
+          </a:fontRef>
+        </p:style>
+      </p:cxnSp>
     </p:spTree>
   </p:cSld>
   <p:clrMapOvr>

</xml_diff>